<commit_message>
Cerrar evidencias finales de calidad y costes
</commit_message>
<xml_diff>
--- a/docs/entrega/presentacion-defensa-tfg.pptx
+++ b/docs/entrega/presentacion-defensa-tfg.pptx
@@ -3403,8 +3403,8 @@
         </p:nvSpPr>
         <p:spPr>
           <a:xfrm>
-            <a:off x="603504" y="347472"/>
-            <a:ext cx="9692640" cy="502920"/>
+            <a:off x="566928" y="320040"/>
+            <a:ext cx="10058400" cy="502920"/>
           </a:xfrm>
           <a:prstGeom prst="rect">
             <a:avLst/>
@@ -3436,8 +3436,8 @@
         </p:nvSpPr>
         <p:spPr>
           <a:xfrm>
-            <a:off x="621792" y="868680"/>
-            <a:ext cx="9692640" cy="320040"/>
+            <a:off x="585216" y="841248"/>
+            <a:ext cx="10058400" cy="320040"/>
           </a:xfrm>
           <a:prstGeom prst="rect">
             <a:avLst/>
@@ -3469,8 +3469,8 @@
         </p:nvSpPr>
         <p:spPr>
           <a:xfrm>
-            <a:off x="603504" y="1243584"/>
-            <a:ext cx="11018520" cy="27432"/>
+            <a:off x="566928" y="1207008"/>
+            <a:ext cx="11064240" cy="27432"/>
           </a:xfrm>
           <a:prstGeom prst="rect">
             <a:avLst/>
@@ -3526,40 +3526,36 @@
           </a:bodyPr>
           <a:lstStyle/>
           <a:p>
-            <a:pPr/>
             <a:r>
               <a:rPr sz="2300">
                 <a:solidFill>
                   <a:srgbClr val="334155"/>
                 </a:solidFill>
               </a:rPr>
-              <a:t>• Abrir el portal desplegado y crear una solicitud de acceso o incidencia.</a:t>
-            </a:r>
-          </a:p>
-          <a:p>
-            <a:pPr/>
+              <a:t>• Abrir el portal desplegado y crear una solicitud.</a:t>
+            </a:r>
+          </a:p>
+          <a:p>
             <a:r>
               <a:rPr sz="2300">
                 <a:solidFill>
                   <a:srgbClr val="334155"/>
                 </a:solidFill>
               </a:rPr>
-              <a:t>• Mostrar la clasificación, SLA, responsable e historial generado.</a:t>
-            </a:r>
-          </a:p>
-          <a:p>
-            <a:pPr/>
+              <a:t>• Mostrar clasificación, SLA, responsable e historial generado.</a:t>
+            </a:r>
+          </a:p>
+          <a:p>
             <a:r>
               <a:rPr sz="2300">
                 <a:solidFill>
                   <a:srgbClr val="334155"/>
                 </a:solidFill>
               </a:rPr>
-              <a:t>• Ejecutar o mostrar Logic App como entrada automática desde otro sistema.</a:t>
-            </a:r>
-          </a:p>
-          <a:p>
-            <a:pPr/>
+              <a:t>• Mostrar Logic App como entrada automática desde otro sistema.</a:t>
+            </a:r>
+          </a:p>
+          <a:p>
             <a:r>
               <a:rPr sz="2300">
                 <a:solidFill>
@@ -3570,7 +3566,6 @@
             </a:r>
           </a:p>
           <a:p>
-            <a:pPr/>
             <a:r>
               <a:rPr sz="2300">
                 <a:solidFill>
@@ -3590,8 +3585,8 @@
         </p:nvSpPr>
         <p:spPr>
           <a:xfrm>
-            <a:off x="603504" y="6510528"/>
-            <a:ext cx="8595360" cy="201168"/>
+            <a:off x="566928" y="6510528"/>
+            <a:ext cx="8686800" cy="182880"/>
           </a:xfrm>
           <a:prstGeom prst="rect">
             <a:avLst/>
@@ -3623,8 +3618,8 @@
         </p:nvSpPr>
         <p:spPr>
           <a:xfrm>
-            <a:off x="10972800" y="6510528"/>
-            <a:ext cx="548640" cy="201168"/>
+            <a:off x="11064240" y="6510528"/>
+            <a:ext cx="457200" cy="182880"/>
           </a:xfrm>
           <a:prstGeom prst="rect">
             <a:avLst/>
@@ -3683,8 +3678,8 @@
         </p:nvSpPr>
         <p:spPr>
           <a:xfrm>
-            <a:off x="603504" y="347472"/>
-            <a:ext cx="9692640" cy="502920"/>
+            <a:off x="566928" y="320040"/>
+            <a:ext cx="10058400" cy="502920"/>
           </a:xfrm>
           <a:prstGeom prst="rect">
             <a:avLst/>
@@ -3716,8 +3711,8 @@
         </p:nvSpPr>
         <p:spPr>
           <a:xfrm>
-            <a:off x="621792" y="868680"/>
-            <a:ext cx="9692640" cy="320040"/>
+            <a:off x="585216" y="841248"/>
+            <a:ext cx="10058400" cy="320040"/>
           </a:xfrm>
           <a:prstGeom prst="rect">
             <a:avLst/>
@@ -3749,8 +3744,8 @@
         </p:nvSpPr>
         <p:spPr>
           <a:xfrm>
-            <a:off x="603504" y="1243584"/>
-            <a:ext cx="11018520" cy="27432"/>
+            <a:off x="566928" y="1207008"/>
+            <a:ext cx="11064240" cy="27432"/>
           </a:xfrm>
           <a:prstGeom prst="rect">
             <a:avLst/>
@@ -3792,7 +3787,7 @@
         </p:nvSpPr>
         <p:spPr>
           <a:xfrm>
-            <a:off x="777240" y="1645920"/>
+            <a:off x="777240" y="1600200"/>
             <a:ext cx="5669280" cy="2560320"/>
           </a:xfrm>
           <a:prstGeom prst="rect">
@@ -3806,7 +3801,6 @@
           </a:bodyPr>
           <a:lstStyle/>
           <a:p>
-            <a:pPr/>
             <a:r>
               <a:rPr sz="2200">
                 <a:solidFill>
@@ -3817,7 +3811,6 @@
             </a:r>
           </a:p>
           <a:p>
-            <a:pPr/>
             <a:r>
               <a:rPr sz="2200">
                 <a:solidFill>
@@ -3828,7 +3821,6 @@
             </a:r>
           </a:p>
           <a:p>
-            <a:pPr/>
             <a:r>
               <a:rPr sz="2200">
                 <a:solidFill>
@@ -3859,7 +3851,7 @@
           </a:solidFill>
           <a:ln>
             <a:solidFill>
-              <a:srgbClr val="DBEAFE"/>
+              <a:srgbClr val="D2E1F0"/>
             </a:solidFill>
           </a:ln>
         </p:spPr>
@@ -3893,8 +3885,8 @@
         </p:nvSpPr>
         <p:spPr>
           <a:xfrm>
-            <a:off x="7205472" y="1746504"/>
-            <a:ext cx="3328416" cy="292608"/>
+            <a:off x="7205472" y="1737360"/>
+            <a:ext cx="3328416" cy="274320"/>
           </a:xfrm>
           <a:prstGeom prst="rect">
             <a:avLst/>
@@ -3908,7 +3900,7 @@
           <a:lstStyle/>
           <a:p>
             <a:r>
-              <a:rPr sz="1900" b="1">
+              <a:rPr sz="1800" b="1">
                 <a:solidFill>
                   <a:srgbClr val="149496"/>
                 </a:solidFill>
@@ -3926,8 +3918,8 @@
         </p:nvSpPr>
         <p:spPr>
           <a:xfrm>
-            <a:off x="7205472" y="2130552"/>
-            <a:ext cx="3328416" cy="1901952"/>
+            <a:off x="7205472" y="2103120"/>
+            <a:ext cx="3328416" cy="1965960"/>
           </a:xfrm>
           <a:prstGeom prst="rect">
             <a:avLst/>
@@ -3941,12 +3933,12 @@
           <a:lstStyle/>
           <a:p>
             <a:r>
-              <a:rPr sz="1450" b="0">
+              <a:rPr sz="1400" b="0">
                 <a:solidFill>
                   <a:srgbClr val="334155"/>
                 </a:solidFill>
               </a:rPr>
-              <a:t>Un flujo empresarial completo: portal, API, base documental, secretos en Key Vault, orquestación con Logic App, monitorización y calidad continua.</a:t>
+              <a:t>Portal, API, Cosmos DB, Key Vault, Logic App, observabilidad y calidad continua integrados en un flujo empresarial.</a:t>
             </a:r>
           </a:p>
         </p:txBody>
@@ -3959,8 +3951,8 @@
         </p:nvSpPr>
         <p:spPr>
           <a:xfrm>
-            <a:off x="603504" y="6510528"/>
-            <a:ext cx="8595360" cy="201168"/>
+            <a:off x="566928" y="6510528"/>
+            <a:ext cx="8686800" cy="182880"/>
           </a:xfrm>
           <a:prstGeom prst="rect">
             <a:avLst/>
@@ -3992,8 +3984,8 @@
         </p:nvSpPr>
         <p:spPr>
           <a:xfrm>
-            <a:off x="10972800" y="6510528"/>
-            <a:ext cx="548640" cy="201168"/>
+            <a:off x="11064240" y="6510528"/>
+            <a:ext cx="457200" cy="182880"/>
           </a:xfrm>
           <a:prstGeom prst="rect">
             <a:avLst/>
@@ -4052,8 +4044,8 @@
         </p:nvSpPr>
         <p:spPr>
           <a:xfrm>
-            <a:off x="603504" y="347472"/>
-            <a:ext cx="9692640" cy="502920"/>
+            <a:off x="566928" y="320040"/>
+            <a:ext cx="10058400" cy="502920"/>
           </a:xfrm>
           <a:prstGeom prst="rect">
             <a:avLst/>
@@ -4085,8 +4077,8 @@
         </p:nvSpPr>
         <p:spPr>
           <a:xfrm>
-            <a:off x="621792" y="868680"/>
-            <a:ext cx="9692640" cy="320040"/>
+            <a:off x="585216" y="841248"/>
+            <a:ext cx="10058400" cy="320040"/>
           </a:xfrm>
           <a:prstGeom prst="rect">
             <a:avLst/>
@@ -4118,8 +4110,8 @@
         </p:nvSpPr>
         <p:spPr>
           <a:xfrm>
-            <a:off x="603504" y="1243584"/>
-            <a:ext cx="11018520" cy="27432"/>
+            <a:off x="566928" y="1207008"/>
+            <a:ext cx="11064240" cy="27432"/>
           </a:xfrm>
           <a:prstGeom prst="rect">
             <a:avLst/>
@@ -4185,8 +4177,8 @@
         </p:nvSpPr>
         <p:spPr>
           <a:xfrm>
-            <a:off x="603504" y="6510528"/>
-            <a:ext cx="8595360" cy="201168"/>
+            <a:off x="566928" y="6510528"/>
+            <a:ext cx="8686800" cy="182880"/>
           </a:xfrm>
           <a:prstGeom prst="rect">
             <a:avLst/>
@@ -4218,8 +4210,8 @@
         </p:nvSpPr>
         <p:spPr>
           <a:xfrm>
-            <a:off x="10972800" y="6510528"/>
-            <a:ext cx="548640" cy="201168"/>
+            <a:off x="11064240" y="6510528"/>
+            <a:ext cx="457200" cy="182880"/>
           </a:xfrm>
           <a:prstGeom prst="rect">
             <a:avLst/>
@@ -4278,8 +4270,8 @@
         </p:nvSpPr>
         <p:spPr>
           <a:xfrm>
-            <a:off x="603504" y="347472"/>
-            <a:ext cx="9692640" cy="502920"/>
+            <a:off x="566928" y="320040"/>
+            <a:ext cx="10058400" cy="502920"/>
           </a:xfrm>
           <a:prstGeom prst="rect">
             <a:avLst/>
@@ -4311,8 +4303,8 @@
         </p:nvSpPr>
         <p:spPr>
           <a:xfrm>
-            <a:off x="621792" y="868680"/>
-            <a:ext cx="9692640" cy="320040"/>
+            <a:off x="585216" y="841248"/>
+            <a:ext cx="10058400" cy="320040"/>
           </a:xfrm>
           <a:prstGeom prst="rect">
             <a:avLst/>
@@ -4344,8 +4336,8 @@
         </p:nvSpPr>
         <p:spPr>
           <a:xfrm>
-            <a:off x="603504" y="1243584"/>
-            <a:ext cx="11018520" cy="27432"/>
+            <a:off x="566928" y="1207008"/>
+            <a:ext cx="11064240" cy="27432"/>
           </a:xfrm>
           <a:prstGeom prst="rect">
             <a:avLst/>
@@ -4387,8 +4379,8 @@
         </p:nvSpPr>
         <p:spPr>
           <a:xfrm>
-            <a:off x="685800" y="1600200"/>
-            <a:ext cx="3154680" cy="2331720"/>
+            <a:off x="640080" y="1554480"/>
+            <a:ext cx="3200400" cy="2194560"/>
           </a:xfrm>
           <a:prstGeom prst="roundRect">
             <a:avLst/>
@@ -4398,7 +4390,7 @@
           </a:solidFill>
           <a:ln>
             <a:solidFill>
-              <a:srgbClr val="DBEAFE"/>
+              <a:srgbClr val="D2E1F0"/>
             </a:solidFill>
           </a:ln>
         </p:spPr>
@@ -4432,8 +4424,8 @@
         </p:nvSpPr>
         <p:spPr>
           <a:xfrm>
-            <a:off x="850392" y="1746504"/>
-            <a:ext cx="2825496" cy="292608"/>
+            <a:off x="804671" y="1691639"/>
+            <a:ext cx="2871216" cy="274320"/>
           </a:xfrm>
           <a:prstGeom prst="rect">
             <a:avLst/>
@@ -4447,7 +4439,7 @@
           <a:lstStyle/>
           <a:p>
             <a:r>
-              <a:rPr sz="1900" b="1">
+              <a:rPr sz="1800" b="1">
                 <a:solidFill>
                   <a:srgbClr val="0078D4"/>
                 </a:solidFill>
@@ -4465,8 +4457,8 @@
         </p:nvSpPr>
         <p:spPr>
           <a:xfrm>
-            <a:off x="850392" y="2130552"/>
-            <a:ext cx="2825496" cy="1673351"/>
+            <a:off x="804671" y="2057400"/>
+            <a:ext cx="2871216" cy="1600200"/>
           </a:xfrm>
           <a:prstGeom prst="rect">
             <a:avLst/>
@@ -4480,12 +4472,12 @@
           <a:lstStyle/>
           <a:p>
             <a:r>
-              <a:rPr sz="1450" b="0">
+              <a:rPr sz="1400" b="0">
                 <a:solidFill>
                   <a:srgbClr val="334155"/>
                 </a:solidFill>
               </a:rPr>
-              <a:t>El único blob JSON era suficiente para el prototipo, pero limitaba concurrencia, consulta y crecimiento. Cosmos DB encaja mejor con datos semiestructurados.</a:t>
+              <a:t>El blob único era suficiente para el prototipo inicial, pero limitaba concurrencia, consulta y crecimiento.</a:t>
             </a:r>
           </a:p>
         </p:txBody>
@@ -4498,8 +4490,8 @@
         </p:nvSpPr>
         <p:spPr>
           <a:xfrm>
-            <a:off x="4480560" y="1600200"/>
-            <a:ext cx="3154680" cy="2331720"/>
+            <a:off x="4480560" y="1554480"/>
+            <a:ext cx="3200400" cy="2194560"/>
           </a:xfrm>
           <a:prstGeom prst="roundRect">
             <a:avLst/>
@@ -4509,7 +4501,7 @@
           </a:solidFill>
           <a:ln>
             <a:solidFill>
-              <a:srgbClr val="DBEAFE"/>
+              <a:srgbClr val="D2E1F0"/>
             </a:solidFill>
           </a:ln>
         </p:spPr>
@@ -4543,8 +4535,8 @@
         </p:nvSpPr>
         <p:spPr>
           <a:xfrm>
-            <a:off x="4645152" y="1746504"/>
-            <a:ext cx="2825496" cy="292608"/>
+            <a:off x="4645152" y="1691639"/>
+            <a:ext cx="2871216" cy="274320"/>
           </a:xfrm>
           <a:prstGeom prst="rect">
             <a:avLst/>
@@ -4558,7 +4550,7 @@
           <a:lstStyle/>
           <a:p>
             <a:r>
-              <a:rPr sz="1900" b="1">
+              <a:rPr sz="1800" b="1">
                 <a:solidFill>
                   <a:srgbClr val="149496"/>
                 </a:solidFill>
@@ -4576,8 +4568,8 @@
         </p:nvSpPr>
         <p:spPr>
           <a:xfrm>
-            <a:off x="4645152" y="2130552"/>
-            <a:ext cx="2825496" cy="1673351"/>
+            <a:off x="4645152" y="2057400"/>
+            <a:ext cx="2871216" cy="1600200"/>
           </a:xfrm>
           <a:prstGeom prst="rect">
             <a:avLst/>
@@ -4591,12 +4583,12 @@
           <a:lstStyle/>
           <a:p>
             <a:r>
-              <a:rPr sz="1450" b="0">
+              <a:rPr sz="1400" b="0">
                 <a:solidFill>
                   <a:srgbClr val="334155"/>
                 </a:solidFill>
               </a:rPr>
-              <a:t>Se añadió un backend opcional, se creó la cuenta Free Tier, se migraron las solicitudes existentes y se cambió STORAGE_MODE a cosmos.</a:t>
+              <a:t>Se creó Cosmos DB Free Tier, se migraron 20 solicitudes y App Service quedó con STORAGE_MODE=cosmos.</a:t>
             </a:r>
           </a:p>
         </p:txBody>
@@ -4609,8 +4601,8 @@
         </p:nvSpPr>
         <p:spPr>
           <a:xfrm>
-            <a:off x="8275320" y="1600200"/>
-            <a:ext cx="3154680" cy="2331720"/>
+            <a:off x="8321040" y="1554480"/>
+            <a:ext cx="3200400" cy="2194560"/>
           </a:xfrm>
           <a:prstGeom prst="roundRect">
             <a:avLst/>
@@ -4620,7 +4612,7 @@
           </a:solidFill>
           <a:ln>
             <a:solidFill>
-              <a:srgbClr val="DBEAFE"/>
+              <a:srgbClr val="D2E1F0"/>
             </a:solidFill>
           </a:ln>
         </p:spPr>
@@ -4654,8 +4646,8 @@
         </p:nvSpPr>
         <p:spPr>
           <a:xfrm>
-            <a:off x="8439912" y="1746504"/>
-            <a:ext cx="2825496" cy="292608"/>
+            <a:off x="8485632" y="1691639"/>
+            <a:ext cx="2871216" cy="274320"/>
           </a:xfrm>
           <a:prstGeom prst="rect">
             <a:avLst/>
@@ -4669,9 +4661,9 @@
           <a:lstStyle/>
           <a:p>
             <a:r>
-              <a:rPr sz="1900" b="1">
-                <a:solidFill>
-                  <a:srgbClr val="168048"/>
+              <a:rPr sz="1800" b="1">
+                <a:solidFill>
+                  <a:srgbClr val="228B53"/>
                 </a:solidFill>
               </a:rPr>
               <a:t>Qué mejora</a:t>
@@ -4687,8 +4679,8 @@
         </p:nvSpPr>
         <p:spPr>
           <a:xfrm>
-            <a:off x="8439912" y="2130552"/>
-            <a:ext cx="2825496" cy="1673351"/>
+            <a:off x="8485632" y="2057400"/>
+            <a:ext cx="2871216" cy="1600200"/>
           </a:xfrm>
           <a:prstGeom prst="rect">
             <a:avLst/>
@@ -4702,12 +4694,12 @@
           <a:lstStyle/>
           <a:p>
             <a:r>
-              <a:rPr sz="1450" b="0">
+              <a:rPr sz="1400" b="0">
                 <a:solidFill>
                   <a:srgbClr val="334155"/>
                 </a:solidFill>
               </a:rPr>
-              <a:t>Cada solicitud se almacena como documento independiente, con partición por tipo, manteniendo el mismo contrato de API y portal.</a:t>
+              <a:t>Cada solicitud se almacena como documento independiente en tfg-solicitudes/solicitudes.</a:t>
             </a:r>
           </a:p>
         </p:txBody>
@@ -4728,8 +4720,8 @@
         </p:blipFill>
         <p:spPr>
           <a:xfrm>
-            <a:off x="1051560" y="4343400"/>
-            <a:ext cx="10058400" cy="1417320"/>
+            <a:off x="1051560" y="4160520"/>
+            <a:ext cx="10058400" cy="1508760"/>
           </a:xfrm>
           <a:prstGeom prst="rect">
             <a:avLst/>
@@ -4744,8 +4736,8 @@
         </p:nvSpPr>
         <p:spPr>
           <a:xfrm>
-            <a:off x="603504" y="6510528"/>
-            <a:ext cx="8595360" cy="201168"/>
+            <a:off x="566928" y="6510528"/>
+            <a:ext cx="8686800" cy="182880"/>
           </a:xfrm>
           <a:prstGeom prst="rect">
             <a:avLst/>
@@ -4777,8 +4769,8 @@
         </p:nvSpPr>
         <p:spPr>
           <a:xfrm>
-            <a:off x="10972800" y="6510528"/>
-            <a:ext cx="548640" cy="201168"/>
+            <a:off x="11064240" y="6510528"/>
+            <a:ext cx="457200" cy="182880"/>
           </a:xfrm>
           <a:prstGeom prst="rect">
             <a:avLst/>
@@ -4837,8 +4829,8 @@
         </p:nvSpPr>
         <p:spPr>
           <a:xfrm>
-            <a:off x="603504" y="347472"/>
-            <a:ext cx="9692640" cy="502920"/>
+            <a:off x="566928" y="320040"/>
+            <a:ext cx="10058400" cy="502920"/>
           </a:xfrm>
           <a:prstGeom prst="rect">
             <a:avLst/>
@@ -4870,8 +4862,8 @@
         </p:nvSpPr>
         <p:spPr>
           <a:xfrm>
-            <a:off x="621792" y="868680"/>
-            <a:ext cx="9692640" cy="320040"/>
+            <a:off x="585216" y="841248"/>
+            <a:ext cx="10058400" cy="320040"/>
           </a:xfrm>
           <a:prstGeom prst="rect">
             <a:avLst/>
@@ -4903,8 +4895,8 @@
         </p:nvSpPr>
         <p:spPr>
           <a:xfrm>
-            <a:off x="603504" y="1243584"/>
-            <a:ext cx="11018520" cy="27432"/>
+            <a:off x="566928" y="1207008"/>
+            <a:ext cx="11064240" cy="27432"/>
           </a:xfrm>
           <a:prstGeom prst="rect">
             <a:avLst/>
@@ -4960,7 +4952,6 @@
           </a:bodyPr>
           <a:lstStyle/>
           <a:p>
-            <a:pPr/>
             <a:r>
               <a:rPr sz="2200">
                 <a:solidFill>
@@ -4971,7 +4962,6 @@
             </a:r>
           </a:p>
           <a:p>
-            <a:pPr/>
             <a:r>
               <a:rPr sz="2200">
                 <a:solidFill>
@@ -4982,18 +4972,16 @@
             </a:r>
           </a:p>
           <a:p>
-            <a:pPr/>
             <a:r>
               <a:rPr sz="2200">
                 <a:solidFill>
                   <a:srgbClr val="334155"/>
                 </a:solidFill>
               </a:rPr>
-              <a:t>• Bandeja de gestión para el equipo TI con filtros, detalle y cambios de estado.</a:t>
-            </a:r>
-          </a:p>
-          <a:p>
-            <a:pPr/>
+              <a:t>• Bandeja de gestión protegida con filtros, detalle y cambios de estado.</a:t>
+            </a:r>
+          </a:p>
+          <a:p>
             <a:r>
               <a:rPr sz="2200">
                 <a:solidFill>
@@ -5004,14 +4992,13 @@
             </a:r>
           </a:p>
           <a:p>
-            <a:pPr/>
             <a:r>
               <a:rPr sz="2200">
                 <a:solidFill>
                   <a:srgbClr val="334155"/>
                 </a:solidFill>
               </a:rPr>
-              <a:t>• Exportación CSV, métricas operativas, health check y pruebas automáticas.</a:t>
+              <a:t>• Exportación CSV, métricas operativas, health check y OpenAPI.</a:t>
             </a:r>
           </a:p>
         </p:txBody>
@@ -5024,8 +5011,8 @@
         </p:nvSpPr>
         <p:spPr>
           <a:xfrm>
-            <a:off x="603504" y="6510528"/>
-            <a:ext cx="8595360" cy="201168"/>
+            <a:off x="566928" y="6510528"/>
+            <a:ext cx="8686800" cy="182880"/>
           </a:xfrm>
           <a:prstGeom prst="rect">
             <a:avLst/>
@@ -5057,8 +5044,8 @@
         </p:nvSpPr>
         <p:spPr>
           <a:xfrm>
-            <a:off x="10972800" y="6510528"/>
-            <a:ext cx="548640" cy="201168"/>
+            <a:off x="11064240" y="6510528"/>
+            <a:ext cx="457200" cy="182880"/>
           </a:xfrm>
           <a:prstGeom prst="rect">
             <a:avLst/>
@@ -5117,8 +5104,8 @@
         </p:nvSpPr>
         <p:spPr>
           <a:xfrm>
-            <a:off x="603504" y="347472"/>
-            <a:ext cx="9692640" cy="502920"/>
+            <a:off x="566928" y="320040"/>
+            <a:ext cx="10058400" cy="502920"/>
           </a:xfrm>
           <a:prstGeom prst="rect">
             <a:avLst/>
@@ -5137,7 +5124,7 @@
                   <a:srgbClr val="0F2F4A"/>
                 </a:solidFill>
               </a:rPr>
-              <a:t>Seguridad</a:t>
+              <a:t>Seguridad y datos</a:t>
             </a:r>
           </a:p>
         </p:txBody>
@@ -5150,8 +5137,8 @@
         </p:nvSpPr>
         <p:spPr>
           <a:xfrm>
-            <a:off x="621792" y="868680"/>
-            <a:ext cx="9692640" cy="320040"/>
+            <a:off x="585216" y="841248"/>
+            <a:ext cx="10058400" cy="320040"/>
           </a:xfrm>
           <a:prstGeom prst="rect">
             <a:avLst/>
@@ -5183,8 +5170,8 @@
         </p:nvSpPr>
         <p:spPr>
           <a:xfrm>
-            <a:off x="603504" y="1243584"/>
-            <a:ext cx="11018520" cy="27432"/>
+            <a:off x="566928" y="1207008"/>
+            <a:ext cx="11064240" cy="27432"/>
           </a:xfrm>
           <a:prstGeom prst="rect">
             <a:avLst/>
@@ -5237,7 +5224,7 @@
           </a:solidFill>
           <a:ln>
             <a:solidFill>
-              <a:srgbClr val="DBEAFE"/>
+              <a:srgbClr val="D2E1F0"/>
             </a:solidFill>
           </a:ln>
         </p:spPr>
@@ -5271,8 +5258,8 @@
         </p:nvSpPr>
         <p:spPr>
           <a:xfrm>
-            <a:off x="850392" y="1746504"/>
-            <a:ext cx="2825496" cy="292608"/>
+            <a:off x="850392" y="1737360"/>
+            <a:ext cx="2825496" cy="274320"/>
           </a:xfrm>
           <a:prstGeom prst="rect">
             <a:avLst/>
@@ -5286,7 +5273,7 @@
           <a:lstStyle/>
           <a:p>
             <a:r>
-              <a:rPr sz="1900" b="1">
+              <a:rPr sz="1800" b="1">
                 <a:solidFill>
                   <a:srgbClr val="0078D4"/>
                 </a:solidFill>
@@ -5304,8 +5291,8 @@
         </p:nvSpPr>
         <p:spPr>
           <a:xfrm>
-            <a:off x="850392" y="2130552"/>
-            <a:ext cx="2825496" cy="1856232"/>
+            <a:off x="850392" y="2103120"/>
+            <a:ext cx="2825496" cy="1920240"/>
           </a:xfrm>
           <a:prstGeom prst="rect">
             <a:avLst/>
@@ -5319,12 +5306,12 @@
           <a:lstStyle/>
           <a:p>
             <a:r>
-              <a:rPr sz="1450" b="0">
+              <a:rPr sz="1400" b="0">
                 <a:solidFill>
                   <a:srgbClr val="334155"/>
                 </a:solidFill>
               </a:rPr>
-              <a:t>Los endpoints operativos requieren Bearer token. La clave se custodia en Key Vault y se facilita al tribunal en el documento de enlaces.</a:t>
+              <a:t>Los endpoints operativos requieren Bearer token. La clave se custodia en Key Vault.</a:t>
             </a:r>
           </a:p>
         </p:txBody>
@@ -5348,7 +5335,7 @@
           </a:solidFill>
           <a:ln>
             <a:solidFill>
-              <a:srgbClr val="DBEAFE"/>
+              <a:srgbClr val="D2E1F0"/>
             </a:solidFill>
           </a:ln>
         </p:spPr>
@@ -5382,8 +5369,8 @@
         </p:nvSpPr>
         <p:spPr>
           <a:xfrm>
-            <a:off x="4645152" y="1746504"/>
-            <a:ext cx="2825496" cy="292608"/>
+            <a:off x="4645152" y="1737360"/>
+            <a:ext cx="2825496" cy="274320"/>
           </a:xfrm>
           <a:prstGeom prst="rect">
             <a:avLst/>
@@ -5397,7 +5384,7 @@
           <a:lstStyle/>
           <a:p>
             <a:r>
-              <a:rPr sz="1900" b="1">
+              <a:rPr sz="1800" b="1">
                 <a:solidFill>
                   <a:srgbClr val="149496"/>
                 </a:solidFill>
@@ -5415,8 +5402,8 @@
         </p:nvSpPr>
         <p:spPr>
           <a:xfrm>
-            <a:off x="4645152" y="2130552"/>
-            <a:ext cx="2825496" cy="1856232"/>
+            <a:off x="4645152" y="2103120"/>
+            <a:ext cx="2825496" cy="1920240"/>
           </a:xfrm>
           <a:prstGeom prst="rect">
             <a:avLst/>
@@ -5430,12 +5417,12 @@
           <a:lstStyle/>
           <a:p>
             <a:r>
-              <a:rPr sz="1450" b="0">
+              <a:rPr sz="1400" b="0">
                 <a:solidFill>
                   <a:srgbClr val="334155"/>
                 </a:solidFill>
               </a:rPr>
-              <a:t>App Service utiliza Managed Identity para acceder a secretos sin guardar credenciales en código fuente.</a:t>
+              <a:t>App Service accede a secretos sin credenciales cloud embebidas en el código.</a:t>
             </a:r>
           </a:p>
         </p:txBody>
@@ -5459,7 +5446,7 @@
           </a:solidFill>
           <a:ln>
             <a:solidFill>
-              <a:srgbClr val="DBEAFE"/>
+              <a:srgbClr val="D2E1F0"/>
             </a:solidFill>
           </a:ln>
         </p:spPr>
@@ -5493,8 +5480,8 @@
         </p:nvSpPr>
         <p:spPr>
           <a:xfrm>
-            <a:off x="8439912" y="1746504"/>
-            <a:ext cx="2825496" cy="292608"/>
+            <a:off x="8439912" y="1737360"/>
+            <a:ext cx="2825496" cy="274320"/>
           </a:xfrm>
           <a:prstGeom prst="rect">
             <a:avLst/>
@@ -5508,12 +5495,12 @@
           <a:lstStyle/>
           <a:p>
             <a:r>
-              <a:rPr sz="1900" b="1">
-                <a:solidFill>
-                  <a:srgbClr val="168048"/>
-                </a:solidFill>
-              </a:rPr>
-              <a:t>Datos</a:t>
+              <a:rPr sz="1800" b="1">
+                <a:solidFill>
+                  <a:srgbClr val="228B53"/>
+                </a:solidFill>
+              </a:rPr>
+              <a:t>Cosmos DB</a:t>
             </a:r>
           </a:p>
         </p:txBody>
@@ -5526,8 +5513,8 @@
         </p:nvSpPr>
         <p:spPr>
           <a:xfrm>
-            <a:off x="8439912" y="2130552"/>
-            <a:ext cx="2825496" cy="1856232"/>
+            <a:off x="8439912" y="2103120"/>
+            <a:ext cx="2825496" cy="1920240"/>
           </a:xfrm>
           <a:prstGeom prst="rect">
             <a:avLst/>
@@ -5541,12 +5528,12 @@
           <a:lstStyle/>
           <a:p>
             <a:r>
-              <a:rPr sz="1450" b="0">
+              <a:rPr sz="1400" b="0">
                 <a:solidFill>
                   <a:srgbClr val="334155"/>
                 </a:solidFill>
               </a:rPr>
-              <a:t>Cosmos DB almacena documentos privados; el portal y la Logic App nunca acceden directamente a la base de datos.</a:t>
+              <a:t>El portal y la Logic App no acceden directamente a la base de datos; toda la lógica pasa por la API.</a:t>
             </a:r>
           </a:p>
         </p:txBody>
@@ -5559,8 +5546,8 @@
         </p:nvSpPr>
         <p:spPr>
           <a:xfrm>
-            <a:off x="603504" y="6510528"/>
-            <a:ext cx="8595360" cy="201168"/>
+            <a:off x="566928" y="6510528"/>
+            <a:ext cx="8686800" cy="182880"/>
           </a:xfrm>
           <a:prstGeom prst="rect">
             <a:avLst/>
@@ -5592,8 +5579,8 @@
         </p:nvSpPr>
         <p:spPr>
           <a:xfrm>
-            <a:off x="10972800" y="6510528"/>
-            <a:ext cx="548640" cy="201168"/>
+            <a:off x="11064240" y="6510528"/>
+            <a:ext cx="457200" cy="182880"/>
           </a:xfrm>
           <a:prstGeom prst="rect">
             <a:avLst/>
@@ -5652,8 +5639,8 @@
         </p:nvSpPr>
         <p:spPr>
           <a:xfrm>
-            <a:off x="603504" y="347472"/>
-            <a:ext cx="9692640" cy="502920"/>
+            <a:off x="566928" y="320040"/>
+            <a:ext cx="10058400" cy="502920"/>
           </a:xfrm>
           <a:prstGeom prst="rect">
             <a:avLst/>
@@ -5685,8 +5672,8 @@
         </p:nvSpPr>
         <p:spPr>
           <a:xfrm>
-            <a:off x="621792" y="868680"/>
-            <a:ext cx="9692640" cy="320040"/>
+            <a:off x="585216" y="841248"/>
+            <a:ext cx="10058400" cy="320040"/>
           </a:xfrm>
           <a:prstGeom prst="rect">
             <a:avLst/>
@@ -5718,8 +5705,8 @@
         </p:nvSpPr>
         <p:spPr>
           <a:xfrm>
-            <a:off x="603504" y="1243584"/>
-            <a:ext cx="11018520" cy="27432"/>
+            <a:off x="566928" y="1207008"/>
+            <a:ext cx="11064240" cy="27432"/>
           </a:xfrm>
           <a:prstGeom prst="rect">
             <a:avLst/>
@@ -5790,7 +5777,7 @@
           </a:solidFill>
           <a:ln>
             <a:solidFill>
-              <a:srgbClr val="DBEAFE"/>
+              <a:srgbClr val="D2E1F0"/>
             </a:solidFill>
           </a:ln>
         </p:spPr>
@@ -5824,8 +5811,8 @@
         </p:nvSpPr>
         <p:spPr>
           <a:xfrm>
-            <a:off x="8485632" y="1883664"/>
-            <a:ext cx="2231136" cy="292608"/>
+            <a:off x="8485632" y="1874519"/>
+            <a:ext cx="2231136" cy="274320"/>
           </a:xfrm>
           <a:prstGeom prst="rect">
             <a:avLst/>
@@ -5839,7 +5826,7 @@
           <a:lstStyle/>
           <a:p>
             <a:r>
-              <a:rPr sz="1900" b="1">
+              <a:rPr sz="1800" b="1">
                 <a:solidFill>
                   <a:srgbClr val="149496"/>
                 </a:solidFill>
@@ -5857,8 +5844,8 @@
         </p:nvSpPr>
         <p:spPr>
           <a:xfrm>
-            <a:off x="8485632" y="2267712"/>
-            <a:ext cx="2231136" cy="1673351"/>
+            <a:off x="8485632" y="2240280"/>
+            <a:ext cx="2231136" cy="1737360"/>
           </a:xfrm>
           <a:prstGeom prst="rect">
             <a:avLst/>
@@ -5872,12 +5859,12 @@
           <a:lstStyle/>
           <a:p>
             <a:r>
-              <a:rPr sz="1450" b="0">
+              <a:rPr sz="1400" b="0">
                 <a:solidFill>
                   <a:srgbClr val="334155"/>
                 </a:solidFill>
               </a:rPr>
-              <a:t>Zube recoge sprints, HU, prioridades y story points. GitHub aporta histórico de commits y releases.</a:t>
+              <a:t>Zube recoge sprints, HU, prioridades y story points. GitHub aporta commits y releases.</a:t>
             </a:r>
           </a:p>
         </p:txBody>
@@ -5890,8 +5877,8 @@
         </p:nvSpPr>
         <p:spPr>
           <a:xfrm>
-            <a:off x="603504" y="6510528"/>
-            <a:ext cx="8595360" cy="201168"/>
+            <a:off x="566928" y="6510528"/>
+            <a:ext cx="8686800" cy="182880"/>
           </a:xfrm>
           <a:prstGeom prst="rect">
             <a:avLst/>
@@ -5923,8 +5910,8 @@
         </p:nvSpPr>
         <p:spPr>
           <a:xfrm>
-            <a:off x="10972800" y="6510528"/>
-            <a:ext cx="548640" cy="201168"/>
+            <a:off x="11064240" y="6510528"/>
+            <a:ext cx="457200" cy="182880"/>
           </a:xfrm>
           <a:prstGeom prst="rect">
             <a:avLst/>
@@ -5983,8 +5970,8 @@
         </p:nvSpPr>
         <p:spPr>
           <a:xfrm>
-            <a:off x="603504" y="347472"/>
-            <a:ext cx="9692640" cy="502920"/>
+            <a:off x="566928" y="320040"/>
+            <a:ext cx="10058400" cy="502920"/>
           </a:xfrm>
           <a:prstGeom prst="rect">
             <a:avLst/>
@@ -6016,8 +6003,8 @@
         </p:nvSpPr>
         <p:spPr>
           <a:xfrm>
-            <a:off x="621792" y="868680"/>
-            <a:ext cx="9692640" cy="320040"/>
+            <a:off x="585216" y="841248"/>
+            <a:ext cx="10058400" cy="320040"/>
           </a:xfrm>
           <a:prstGeom prst="rect">
             <a:avLst/>
@@ -6049,8 +6036,8 @@
         </p:nvSpPr>
         <p:spPr>
           <a:xfrm>
-            <a:off x="603504" y="1243584"/>
-            <a:ext cx="11018520" cy="27432"/>
+            <a:off x="566928" y="1207008"/>
+            <a:ext cx="11064240" cy="27432"/>
           </a:xfrm>
           <a:prstGeom prst="rect">
             <a:avLst/>
@@ -6103,7 +6090,7 @@
           </a:solidFill>
           <a:ln>
             <a:solidFill>
-              <a:srgbClr val="DBEAFE"/>
+              <a:srgbClr val="D2E1F0"/>
             </a:solidFill>
           </a:ln>
         </p:spPr>
@@ -6137,8 +6124,8 @@
         </p:nvSpPr>
         <p:spPr>
           <a:xfrm>
-            <a:off x="896112" y="1746504"/>
-            <a:ext cx="2596896" cy="292608"/>
+            <a:off x="896112" y="1737360"/>
+            <a:ext cx="2596896" cy="274320"/>
           </a:xfrm>
           <a:prstGeom prst="rect">
             <a:avLst/>
@@ -6152,9 +6139,9 @@
           <a:lstStyle/>
           <a:p>
             <a:r>
-              <a:rPr sz="1900" b="1">
-                <a:solidFill>
-                  <a:srgbClr val="168048"/>
+              <a:rPr sz="1800" b="1">
+                <a:solidFill>
+                  <a:srgbClr val="228B53"/>
                 </a:solidFill>
               </a:rPr>
               <a:t>Pruebas</a:t>
@@ -6170,8 +6157,8 @@
         </p:nvSpPr>
         <p:spPr>
           <a:xfrm>
-            <a:off x="896112" y="2130552"/>
-            <a:ext cx="2596896" cy="1490472"/>
+            <a:off x="896112" y="2103120"/>
+            <a:ext cx="2596896" cy="1554480"/>
           </a:xfrm>
           <a:prstGeom prst="rect">
             <a:avLst/>
@@ -6185,7 +6172,7 @@
           <a:lstStyle/>
           <a:p>
             <a:r>
-              <a:rPr sz="1450" b="0">
+              <a:rPr sz="1400" b="0">
                 <a:solidFill>
                   <a:srgbClr val="334155"/>
                 </a:solidFill>
@@ -6214,7 +6201,7 @@
           </a:solidFill>
           <a:ln>
             <a:solidFill>
-              <a:srgbClr val="DBEAFE"/>
+              <a:srgbClr val="D2E1F0"/>
             </a:solidFill>
           </a:ln>
         </p:spPr>
@@ -6248,8 +6235,8 @@
         </p:nvSpPr>
         <p:spPr>
           <a:xfrm>
-            <a:off x="4690872" y="1746504"/>
-            <a:ext cx="2596896" cy="292608"/>
+            <a:off x="4690872" y="1737360"/>
+            <a:ext cx="2596896" cy="274320"/>
           </a:xfrm>
           <a:prstGeom prst="rect">
             <a:avLst/>
@@ -6263,7 +6250,7 @@
           <a:lstStyle/>
           <a:p>
             <a:r>
-              <a:rPr sz="1900" b="1">
+              <a:rPr sz="1800" b="1">
                 <a:solidFill>
                   <a:srgbClr val="0078D4"/>
                 </a:solidFill>
@@ -6281,8 +6268,8 @@
         </p:nvSpPr>
         <p:spPr>
           <a:xfrm>
-            <a:off x="4690872" y="2130552"/>
-            <a:ext cx="2596896" cy="1490472"/>
+            <a:off x="4690872" y="2103120"/>
+            <a:ext cx="2596896" cy="1554480"/>
           </a:xfrm>
           <a:prstGeom prst="rect">
             <a:avLst/>
@@ -6296,12 +6283,12 @@
           <a:lstStyle/>
           <a:p>
             <a:r>
-              <a:rPr sz="1450" b="0">
+              <a:rPr sz="1400" b="0">
                 <a:solidFill>
                   <a:srgbClr val="334155"/>
                 </a:solidFill>
               </a:rPr>
-              <a:t>Quality Gate aprobado, sin issues de seguridad abiertos y duplicación controlada.</a:t>
+              <a:t>Quality Gate aprobado en el análisis final del 30 de junio.</a:t>
             </a:r>
           </a:p>
         </p:txBody>
@@ -6325,7 +6312,7 @@
           </a:solidFill>
           <a:ln>
             <a:solidFill>
-              <a:srgbClr val="DBEAFE"/>
+              <a:srgbClr val="D2E1F0"/>
             </a:solidFill>
           </a:ln>
         </p:spPr>
@@ -6359,8 +6346,8 @@
         </p:nvSpPr>
         <p:spPr>
           <a:xfrm>
-            <a:off x="8485632" y="1746504"/>
-            <a:ext cx="2596896" cy="292608"/>
+            <a:off x="8485632" y="1737360"/>
+            <a:ext cx="2596896" cy="274320"/>
           </a:xfrm>
           <a:prstGeom prst="rect">
             <a:avLst/>
@@ -6374,7 +6361,7 @@
           <a:lstStyle/>
           <a:p>
             <a:r>
-              <a:rPr sz="1900" b="1">
+              <a:rPr sz="1800" b="1">
                 <a:solidFill>
                   <a:srgbClr val="149496"/>
                 </a:solidFill>
@@ -6392,8 +6379,8 @@
         </p:nvSpPr>
         <p:spPr>
           <a:xfrm>
-            <a:off x="8485632" y="2130552"/>
-            <a:ext cx="2596896" cy="1490472"/>
+            <a:off x="8485632" y="2103120"/>
+            <a:ext cx="2596896" cy="1554480"/>
           </a:xfrm>
           <a:prstGeom prst="rect">
             <a:avLst/>
@@ -6407,12 +6394,12 @@
           <a:lstStyle/>
           <a:p>
             <a:r>
-              <a:rPr sz="1450" b="0">
+              <a:rPr sz="1400" b="0">
                 <a:solidFill>
                   <a:srgbClr val="334155"/>
                 </a:solidFill>
               </a:rPr>
-              <a:t>/health confirma la persistencia activa en Cosmos DB y los endpoints de demo responden en la nube.</a:t>
+              <a:t>/health confirma storage_mode=cosmos y los endpoints responden en la nube.</a:t>
             </a:r>
           </a:p>
         </p:txBody>
@@ -6449,8 +6436,8 @@
         </p:nvSpPr>
         <p:spPr>
           <a:xfrm>
-            <a:off x="603504" y="6510528"/>
-            <a:ext cx="8595360" cy="201168"/>
+            <a:off x="566928" y="6510528"/>
+            <a:ext cx="8686800" cy="182880"/>
           </a:xfrm>
           <a:prstGeom prst="rect">
             <a:avLst/>
@@ -6482,8 +6469,8 @@
         </p:nvSpPr>
         <p:spPr>
           <a:xfrm>
-            <a:off x="10972800" y="6510528"/>
-            <a:ext cx="548640" cy="201168"/>
+            <a:off x="11064240" y="6510528"/>
+            <a:ext cx="457200" cy="182880"/>
           </a:xfrm>
           <a:prstGeom prst="rect">
             <a:avLst/>
@@ -6542,8 +6529,8 @@
         </p:nvSpPr>
         <p:spPr>
           <a:xfrm>
-            <a:off x="603504" y="347472"/>
-            <a:ext cx="9692640" cy="502920"/>
+            <a:off x="566928" y="320040"/>
+            <a:ext cx="10058400" cy="502920"/>
           </a:xfrm>
           <a:prstGeom prst="rect">
             <a:avLst/>
@@ -6562,7 +6549,7 @@
                   <a:srgbClr val="0F2F4A"/>
                 </a:solidFill>
               </a:rPr>
-              <a:t>Limitaciones y decisiones</a:t>
+              <a:t>Costes y buenas prácticas</a:t>
             </a:r>
           </a:p>
         </p:txBody>
@@ -6575,8 +6562,8 @@
         </p:nvSpPr>
         <p:spPr>
           <a:xfrm>
-            <a:off x="621792" y="868680"/>
-            <a:ext cx="9692640" cy="320040"/>
+            <a:off x="585216" y="841248"/>
+            <a:ext cx="10058400" cy="320040"/>
           </a:xfrm>
           <a:prstGeom prst="rect">
             <a:avLst/>
@@ -6595,7 +6582,7 @@
                   <a:srgbClr val="334155"/>
                 </a:solidFill>
               </a:rPr>
-              <a:t>Alcance realista y justificable</a:t>
+              <a:t>Alcance académico con recursos controlados</a:t>
             </a:r>
           </a:p>
         </p:txBody>
@@ -6608,8 +6595,8 @@
         </p:nvSpPr>
         <p:spPr>
           <a:xfrm>
-            <a:off x="603504" y="1243584"/>
-            <a:ext cx="11018520" cy="27432"/>
+            <a:off x="566928" y="1207008"/>
+            <a:ext cx="11064240" cy="27432"/>
           </a:xfrm>
           <a:prstGeom prst="rect">
             <a:avLst/>
@@ -6643,16 +6630,40 @@
           </a:p>
         </p:txBody>
       </p:sp>
-      <p:sp>
-        <p:nvSpPr>
-          <p:cNvPr id="5" name="TextBox 4"/>
+      <p:pic>
+        <p:nvPicPr>
+          <p:cNvPr id="5" name="Picture 4" descr="grafico_costes_estimados.png"/>
+          <p:cNvPicPr>
+            <a:picLocks noChangeAspect="1"/>
+          </p:cNvPicPr>
+          <p:nvPr/>
+        </p:nvPicPr>
+        <p:blipFill>
+          <a:blip r:embed="rId2"/>
+          <a:stretch>
+            <a:fillRect/>
+          </a:stretch>
+        </p:blipFill>
+        <p:spPr>
+          <a:xfrm>
+            <a:off x="502920" y="1325880"/>
+            <a:ext cx="10972800" cy="4892040"/>
+          </a:xfrm>
+          <a:prstGeom prst="rect">
+            <a:avLst/>
+          </a:prstGeom>
+        </p:spPr>
+      </p:pic>
+      <p:sp>
+        <p:nvSpPr>
+          <p:cNvPr id="6" name="TextBox 5"/>
           <p:cNvSpPr txBox="1"/>
           <p:nvPr/>
         </p:nvSpPr>
         <p:spPr>
           <a:xfrm>
-            <a:off x="868680" y="1600200"/>
-            <a:ext cx="10241280" cy="3383280"/>
+            <a:off x="566928" y="6510528"/>
+            <a:ext cx="8686800" cy="182880"/>
           </a:xfrm>
           <a:prstGeom prst="rect">
             <a:avLst/>
@@ -6665,73 +6676,6 @@
           </a:bodyPr>
           <a:lstStyle/>
           <a:p>
-            <a:pPr/>
-            <a:r>
-              <a:rPr sz="2200">
-                <a:solidFill>
-                  <a:srgbClr val="334155"/>
-                </a:solidFill>
-              </a:rPr>
-              <a:t>• No sustituye a una plataforma ITSM comercial; es un prototipo cloud académico validado.</a:t>
-            </a:r>
-          </a:p>
-          <a:p>
-            <a:pPr/>
-            <a:r>
-              <a:rPr sz="2200">
-                <a:solidFill>
-                  <a:srgbClr val="334155"/>
-                </a:solidFill>
-              </a:rPr>
-              <a:t>• La clasificación es ligera y basada en reglas, adecuada para explicar el valor sin depender de modelos externos.</a:t>
-            </a:r>
-          </a:p>
-          <a:p>
-            <a:pPr/>
-            <a:r>
-              <a:rPr sz="2200">
-                <a:solidFill>
-                  <a:srgbClr val="334155"/>
-                </a:solidFill>
-              </a:rPr>
-              <a:t>• Cosmos DB mejora concurrencia y escalabilidad frente al blob inicial, manteniendo bajo coste con Free Tier.</a:t>
-            </a:r>
-          </a:p>
-          <a:p>
-            <a:pPr/>
-            <a:r>
-              <a:rPr sz="2200">
-                <a:solidFill>
-                  <a:srgbClr val="334155"/>
-                </a:solidFill>
-              </a:rPr>
-              <a:t>• La solución se diseñó para demostración segura: sin datos personales reales ni secretos en repositorio.</a:t>
-            </a:r>
-          </a:p>
-        </p:txBody>
-      </p:sp>
-      <p:sp>
-        <p:nvSpPr>
-          <p:cNvPr id="6" name="TextBox 5"/>
-          <p:cNvSpPr txBox="1"/>
-          <p:nvPr/>
-        </p:nvSpPr>
-        <p:spPr>
-          <a:xfrm>
-            <a:off x="603504" y="6510528"/>
-            <a:ext cx="8595360" cy="201168"/>
-          </a:xfrm>
-          <a:prstGeom prst="rect">
-            <a:avLst/>
-          </a:prstGeom>
-          <a:noFill/>
-        </p:spPr>
-        <p:txBody>
-          <a:bodyPr wrap="none">
-            <a:spAutoFit/>
-          </a:bodyPr>
-          <a:lstStyle/>
-          <a:p>
             <a:r>
               <a:rPr sz="1000" b="0">
                 <a:solidFill>
@@ -6751,8 +6695,8 @@
         </p:nvSpPr>
         <p:spPr>
           <a:xfrm>
-            <a:off x="10972800" y="6510528"/>
-            <a:ext cx="548640" cy="201168"/>
+            <a:off x="11064240" y="6510528"/>
+            <a:ext cx="457200" cy="182880"/>
           </a:xfrm>
           <a:prstGeom prst="rect">
             <a:avLst/>

</xml_diff>